<commit_message>
Add CC-licensed gas leaf blower photo to slide 5
Image: Leaf blower in action, Washington DC by Daniel Lobo (CC BY 2.0)
via Wikimedia Commons. Updated storyboard notes and replaced
placeholder in slide generator with actual image on the right side.
</commit_message>
<xml_diff>
--- a/Town_Meeting_Video_Slides.pptx
+++ b/Town_Meeting_Video_Slides.pptx
@@ -4732,16 +4732,40 @@
           </a:p>
         </p:txBody>
       </p:sp>
-      <p:sp>
-        <p:nvSpPr>
-          <p:cNvPr id="4" name="TextBox 3"/>
+      <p:pic>
+        <p:nvPicPr>
+          <p:cNvPr id="4" name="Picture 3" descr="gas_leaf_blower.jpg"/>
+          <p:cNvPicPr>
+            <a:picLocks noChangeAspect="1"/>
+          </p:cNvPicPr>
+          <p:nvPr/>
+        </p:nvPicPr>
+        <p:blipFill>
+          <a:blip r:embed="rId3"/>
+          <a:stretch>
+            <a:fillRect/>
+          </a:stretch>
+        </p:blipFill>
+        <p:spPr>
+          <a:xfrm>
+            <a:off x="5029200" y="1097280"/>
+            <a:ext cx="3840480" cy="2880360"/>
+          </a:xfrm>
+          <a:prstGeom prst="rect">
+            <a:avLst/>
+          </a:prstGeom>
+        </p:spPr>
+      </p:pic>
+      <p:sp>
+        <p:nvSpPr>
+          <p:cNvPr id="5" name="TextBox 4"/>
           <p:cNvSpPr txBox="1"/>
           <p:nvPr/>
         </p:nvSpPr>
         <p:spPr>
           <a:xfrm>
             <a:off x="311810" y="1005840"/>
-            <a:ext cx="7772400" cy="3200400"/>
+            <a:ext cx="4572000" cy="3200400"/>
           </a:xfrm>
           <a:prstGeom prst="rect">
             <a:avLst/>
@@ -4808,25 +4832,6 @@
             </a:pPr>
             <a:r>
               <a:t>They wanted people to switch to quieter, electric blowers — or just use a rake!</a:t>
-            </a:r>
-          </a:p>
-          <a:p>
-            <a:pPr>
-              <a:lnSpc>
-                <a:spcPts val="1920"/>
-              </a:lnSpc>
-              <a:spcAft>
-                <a:spcPts val="400"/>
-              </a:spcAft>
-              <a:defRPr sz="1600">
-                <a:solidFill>
-                  <a:srgbClr val="1A1A1A"/>
-                </a:solidFill>
-                <a:latin typeface="Calibri"/>
-              </a:defRPr>
-            </a:pPr>
-            <a:r>
-              <a:t>[PLACEHOLDER: Insert photo of gas leaf blower here]</a:t>
             </a:r>
           </a:p>
         </p:txBody>

</xml_diff>

<commit_message>
Add artificial turf field photo (Memorial Field) to slide 8
- Download Memorial Field turf photo from Natick Report
- Update generate_slides.py to embed image on right side of slide 8
- Update storyboard.md slide 8 visual description and placeholder notes
- Regenerate Town_Meeting_Video_Slides.pptx
</commit_message>
<xml_diff>
--- a/Town_Meeting_Video_Slides.pptx
+++ b/Town_Meeting_Video_Slides.pptx
@@ -5516,16 +5516,40 @@
           </a:p>
         </p:txBody>
       </p:sp>
-      <p:sp>
-        <p:nvSpPr>
-          <p:cNvPr id="4" name="TextBox 3"/>
+      <p:pic>
+        <p:nvPicPr>
+          <p:cNvPr id="4" name="Picture 3" descr="artificial_turf_field.jpg"/>
+          <p:cNvPicPr>
+            <a:picLocks noChangeAspect="1"/>
+          </p:cNvPicPr>
+          <p:nvPr/>
+        </p:nvPicPr>
+        <p:blipFill>
+          <a:blip r:embed="rId3"/>
+          <a:stretch>
+            <a:fillRect/>
+          </a:stretch>
+        </p:blipFill>
+        <p:spPr>
+          <a:xfrm>
+            <a:off x="5029200" y="1097280"/>
+            <a:ext cx="3840480" cy="2880360"/>
+          </a:xfrm>
+          <a:prstGeom prst="rect">
+            <a:avLst/>
+          </a:prstGeom>
+        </p:spPr>
+      </p:pic>
+      <p:sp>
+        <p:nvSpPr>
+          <p:cNvPr id="5" name="TextBox 4"/>
           <p:cNvSpPr txBox="1"/>
           <p:nvPr/>
         </p:nvSpPr>
         <p:spPr>
           <a:xfrm>
             <a:off x="311810" y="1005840"/>
-            <a:ext cx="7772400" cy="3200400"/>
+            <a:ext cx="4572000" cy="3200400"/>
           </a:xfrm>
           <a:prstGeom prst="rect">
             <a:avLst/>
@@ -5592,25 +5616,6 @@
             </a:pPr>
             <a:r>
               <a:t>Supporters wanted time to study health and environmental risks before building more.</a:t>
-            </a:r>
-          </a:p>
-          <a:p>
-            <a:pPr>
-              <a:lnSpc>
-                <a:spcPts val="1920"/>
-              </a:lnSpc>
-              <a:spcAft>
-                <a:spcPts val="400"/>
-              </a:spcAft>
-              <a:defRPr sz="1600">
-                <a:solidFill>
-                  <a:srgbClr val="1A1A1A"/>
-                </a:solidFill>
-                <a:latin typeface="Calibri"/>
-              </a:defRPr>
-            </a:pPr>
-            <a:r>
-              <a:t>[PLACEHOLDER: Insert photo of artificial turf field here]</a:t>
             </a:r>
           </a:p>
         </p:txBody>

</xml_diff>

<commit_message>
Remove credits slide (slide 12)
- Delete slide 12 (credits/copyright) from generator and storyboard
- Update storyboard to 11 slides, adjust duration to 2:30-2:45
- Move leaf blower CC attribution note to video description
- Regenerate PPTX
</commit_message>
<xml_diff>
--- a/Town_Meeting_Video_Slides.pptx
+++ b/Town_Meeting_Video_Slides.pptx
@@ -16,7 +16,6 @@
     <p:sldId id="264" r:id="rId15"/>
     <p:sldId id="265" r:id="rId16"/>
     <p:sldId id="266" r:id="rId17"/>
-    <p:sldId id="267" r:id="rId18"/>
   </p:sldIdLst>
   <p:sldSz cx="9144000" cy="5143500" type="screen4x3"/>
   <p:notesSz cx="6858000" cy="9144000"/>
@@ -3762,145 +3761,6 @@
             </a:pPr>
             <a:r>
               <a:t>Everyone’s vote is equal. That’s democracy in action!</a:t>
-            </a:r>
-          </a:p>
-        </p:txBody>
-      </p:sp>
-    </p:spTree>
-  </p:cSld>
-  <p:clrMapOvr>
-    <a:masterClrMapping/>
-  </p:clrMapOvr>
-</p:sld>
-</file>
-
-<file path=ppt/slides/slide12.xml><?xml version="1.0" encoding="utf-8"?>
-<p:sld xmlns:a="http://schemas.openxmlformats.org/drawingml/2006/main" xmlns:p="http://schemas.openxmlformats.org/presentationml/2006/main" xmlns:r="http://schemas.openxmlformats.org/officeDocument/2006/relationships">
-  <p:cSld>
-    <p:bg>
-      <p:bgPr>
-        <a:solidFill>
-          <a:srgbClr val="1B3A5C"/>
-        </a:solidFill>
-        <a:effectLst/>
-      </p:bgPr>
-    </p:bg>
-    <p:spTree>
-      <p:nvGrpSpPr>
-        <p:cNvPr id="1" name=""/>
-        <p:cNvGrpSpPr/>
-        <p:nvPr/>
-      </p:nvGrpSpPr>
-      <p:grpSpPr/>
-      <p:pic>
-        <p:nvPicPr>
-          <p:cNvPr id="2" name="Picture 1" descr="image.png"/>
-          <p:cNvPicPr>
-            <a:picLocks noChangeAspect="1"/>
-          </p:cNvPicPr>
-          <p:nvPr/>
-        </p:nvPicPr>
-        <p:blipFill>
-          <a:blip r:embed="rId2"/>
-          <a:stretch>
-            <a:fillRect/>
-          </a:stretch>
-        </p:blipFill>
-        <p:spPr>
-          <a:xfrm>
-            <a:off x="8128101" y="0"/>
-            <a:ext cx="1015898" cy="1015898"/>
-          </a:xfrm>
-          <a:prstGeom prst="rect">
-            <a:avLst/>
-          </a:prstGeom>
-        </p:spPr>
-      </p:pic>
-      <p:sp>
-        <p:nvSpPr>
-          <p:cNvPr id="3" name="TextBox 2"/>
-          <p:cNvSpPr txBox="1"/>
-          <p:nvPr/>
-        </p:nvSpPr>
-        <p:spPr>
-          <a:xfrm>
-            <a:off x="731520" y="1097280"/>
-            <a:ext cx="7680960" cy="640080"/>
-          </a:xfrm>
-          <a:prstGeom prst="rect">
-            <a:avLst/>
-          </a:prstGeom>
-          <a:noFill/>
-        </p:spPr>
-        <p:txBody>
-          <a:bodyPr wrap="square">
-            <a:spAutoFit/>
-          </a:bodyPr>
-          <a:lstStyle/>
-          <a:p>
-            <a:pPr algn="ctr">
-              <a:defRPr sz="2800" b="1">
-                <a:solidFill>
-                  <a:srgbClr val="FFFFFF"/>
-                </a:solidFill>
-                <a:latin typeface="Calibri"/>
-              </a:defRPr>
-            </a:pPr>
-            <a:r>
-              <a:t>Credits</a:t>
-            </a:r>
-          </a:p>
-        </p:txBody>
-      </p:sp>
-      <p:sp>
-        <p:nvSpPr>
-          <p:cNvPr id="4" name="TextBox 3"/>
-          <p:cNvSpPr txBox="1"/>
-          <p:nvPr/>
-        </p:nvSpPr>
-        <p:spPr>
-          <a:xfrm>
-            <a:off x="731520" y="2103120"/>
-            <a:ext cx="7680960" cy="1828800"/>
-          </a:xfrm>
-          <a:prstGeom prst="rect">
-            <a:avLst/>
-          </a:prstGeom>
-          <a:noFill/>
-        </p:spPr>
-        <p:txBody>
-          <a:bodyPr wrap="square">
-            <a:spAutoFit/>
-          </a:bodyPr>
-          <a:lstStyle/>
-          <a:p>
-            <a:pPr algn="ctr">
-              <a:defRPr sz="1600" b="0">
-                <a:solidFill>
-                  <a:srgbClr val="BBD5ED"/>
-                </a:solidFill>
-                <a:latin typeface="Calibri"/>
-              </a:defRPr>
-            </a:pPr>
-            <a:r>
-              <a:t>Sources:</a:t>
-            </a:r>
-            <a:br/>
-            <a:r>
-              <a:t>Natick Report · EcoNatick · Town of Natick</a:t>
-            </a:r>
-            <a:br/>
-            <a:r>
-              <a:t>Telvue Recording of Fall 2025 Town Meeting</a:t>
-            </a:r>
-            <a:br/>
-            <a:br/>
-            <a:r>
-              <a:t>Produced for Natick Public Schools</a:t>
-            </a:r>
-            <a:br/>
-            <a:r>
-              <a:t>© 2025</a:t>
             </a:r>
           </a:p>
         </p:txBody>

</xml_diff>

<commit_message>
Remove 'Natick Public Schools' from title slide
</commit_message>
<xml_diff>
--- a/Town_Meeting_Video_Slides.pptx
+++ b/Town_Meeting_Video_Slides.pptx
@@ -3166,42 +3166,6 @@
             <a:br/>
             <a:r>
               <a:t>Two Big Decisions in Natick</a:t>
-            </a:r>
-          </a:p>
-        </p:txBody>
-      </p:sp>
-      <p:sp>
-        <p:nvSpPr>
-          <p:cNvPr id="4" name="TextBox 3"/>
-          <p:cNvSpPr txBox="1"/>
-          <p:nvPr/>
-        </p:nvSpPr>
-        <p:spPr>
-          <a:xfrm>
-            <a:off x="731520" y="2926080"/>
-            <a:ext cx="7680960" cy="548640"/>
-          </a:xfrm>
-          <a:prstGeom prst="rect">
-            <a:avLst/>
-          </a:prstGeom>
-          <a:noFill/>
-        </p:spPr>
-        <p:txBody>
-          <a:bodyPr wrap="square">
-            <a:spAutoFit/>
-          </a:bodyPr>
-          <a:lstStyle/>
-          <a:p>
-            <a:pPr algn="ctr">
-              <a:defRPr sz="1800" b="0">
-                <a:solidFill>
-                  <a:srgbClr val="BBD5ED"/>
-                </a:solidFill>
-                <a:latin typeface="Calibri"/>
-              </a:defRPr>
-            </a:pPr>
-            <a:r>
-              <a:t>A Natick Public Schools Learning Video</a:t>
             </a:r>
           </a:p>
         </p:txBody>

</xml_diff>

<commit_message>
Change title slide to white background with blue text for seal readability
</commit_message>
<xml_diff>
--- a/Town_Meeting_Video_Slides.pptx
+++ b/Town_Meeting_Video_Slides.pptx
@@ -3094,7 +3094,7 @@
     <p:bg>
       <p:bgPr>
         <a:solidFill>
-          <a:srgbClr val="1B3A5C"/>
+          <a:srgbClr val="FFFFFF"/>
         </a:solidFill>
         <a:effectLst/>
       </p:bgPr>
@@ -3155,7 +3155,7 @@
             <a:pPr algn="ctr">
               <a:defRPr sz="3200" b="1">
                 <a:solidFill>
-                  <a:srgbClr val="FFFFFF"/>
+                  <a:srgbClr val="1B3A5C"/>
                 </a:solidFill>
                 <a:latin typeface="Calibri"/>
               </a:defRPr>

</xml_diff>

<commit_message>
Replace text arrow with shape-based flow diagram on slide 2
</commit_message>
<xml_diff>
--- a/Town_Meeting_Video_Slides.pptx
+++ b/Town_Meeting_Video_Slides.pptx
@@ -3824,7 +3824,7 @@
         <p:spPr>
           <a:xfrm>
             <a:off x="311810" y="1005840"/>
-            <a:ext cx="7772400" cy="3200400"/>
+            <a:ext cx="7772400" cy="2011680"/>
           </a:xfrm>
           <a:prstGeom prst="rect">
             <a:avLst/>
@@ -3916,36 +3916,324 @@
       </p:sp>
       <p:sp>
         <p:nvSpPr>
-          <p:cNvPr id="5" name="TextBox 4"/>
-          <p:cNvSpPr txBox="1"/>
+          <p:cNvPr id="5" name="Rounded Rectangle 4"/>
+          <p:cNvSpPr/>
           <p:nvPr/>
         </p:nvSpPr>
         <p:spPr>
           <a:xfrm>
-            <a:off x="311810" y="4114800"/>
-            <a:ext cx="4572000" cy="365760"/>
-          </a:xfrm>
-          <a:prstGeom prst="rect">
+            <a:off x="891539" y="3474720"/>
+            <a:ext cx="1463040" cy="640080"/>
+          </a:xfrm>
+          <a:prstGeom prst="roundRect">
             <a:avLst/>
           </a:prstGeom>
-          <a:noFill/>
-        </p:spPr>
-        <p:txBody>
-          <a:bodyPr wrap="square">
-            <a:spAutoFit/>
-          </a:bodyPr>
+          <a:solidFill>
+            <a:srgbClr val="FFFFFF"/>
+          </a:solidFill>
+          <a:ln w="19050">
+            <a:solidFill>
+              <a:srgbClr val="1B3A5C"/>
+            </a:solidFill>
+          </a:ln>
+        </p:spPr>
+        <p:style>
+          <a:lnRef idx="1">
+            <a:schemeClr val="accent1"/>
+          </a:lnRef>
+          <a:fillRef idx="3">
+            <a:schemeClr val="accent1"/>
+          </a:fillRef>
+          <a:effectRef idx="2">
+            <a:schemeClr val="accent1"/>
+          </a:effectRef>
+          <a:fontRef idx="minor">
+            <a:schemeClr val="lt1"/>
+          </a:fontRef>
+        </p:style>
+        <p:txBody>
+          <a:bodyPr rtlCol="0" anchor="ctr" wrap="square"/>
           <a:lstStyle/>
           <a:p>
             <a:pPr algn="ctr">
-              <a:defRPr sz="1600" b="1">
-                <a:solidFill>
-                  <a:srgbClr val="2E86AB"/>
-                </a:solidFill>
-                <a:latin typeface="Calibri"/>
-              </a:defRPr>
-            </a:pPr>
-            <a:r>
-              <a:t>Residents → Town Meeting → Vote → Decision</a:t>
+              <a:defRPr sz="1400" b="1">
+                <a:solidFill>
+                  <a:srgbClr val="1B3A5C"/>
+                </a:solidFill>
+              </a:defRPr>
+            </a:pPr>
+            <a:r>
+              <a:t>Residents</a:t>
+            </a:r>
+          </a:p>
+        </p:txBody>
+      </p:sp>
+      <p:cxnSp>
+        <p:nvCxnSpPr>
+          <p:cNvPr id="6" name="Connector 5"/>
+          <p:cNvCxnSpPr/>
+          <p:nvPr/>
+        </p:nvCxnSpPr>
+        <p:spPr>
+          <a:xfrm>
+            <a:off x="2400299" y="3794759"/>
+            <a:ext cx="411480" cy="0"/>
+          </a:xfrm>
+          <a:prstGeom prst="line">
+            <a:avLst/>
+          </a:prstGeom>
+          <a:ln w="25400">
+            <a:solidFill>
+              <a:srgbClr val="2E86AB"/>
+            </a:solidFill>
+            <a:tailEnd type="triangle" w="med" len="med"/>
+          </a:ln>
+        </p:spPr>
+        <p:style>
+          <a:lnRef idx="2">
+            <a:schemeClr val="accent1"/>
+          </a:lnRef>
+          <a:fillRef idx="0">
+            <a:schemeClr val="accent1"/>
+          </a:fillRef>
+          <a:effectRef idx="1">
+            <a:schemeClr val="accent1"/>
+          </a:effectRef>
+          <a:fontRef idx="minor">
+            <a:schemeClr val="tx1"/>
+          </a:fontRef>
+        </p:style>
+      </p:cxnSp>
+      <p:sp>
+        <p:nvSpPr>
+          <p:cNvPr id="7" name="Rounded Rectangle 6"/>
+          <p:cNvSpPr/>
+          <p:nvPr/>
+        </p:nvSpPr>
+        <p:spPr>
+          <a:xfrm>
+            <a:off x="2857500" y="3474720"/>
+            <a:ext cx="1463040" cy="640080"/>
+          </a:xfrm>
+          <a:prstGeom prst="roundRect">
+            <a:avLst/>
+          </a:prstGeom>
+          <a:solidFill>
+            <a:srgbClr val="FFFFFF"/>
+          </a:solidFill>
+          <a:ln w="19050">
+            <a:solidFill>
+              <a:srgbClr val="1B3A5C"/>
+            </a:solidFill>
+          </a:ln>
+        </p:spPr>
+        <p:style>
+          <a:lnRef idx="1">
+            <a:schemeClr val="accent1"/>
+          </a:lnRef>
+          <a:fillRef idx="3">
+            <a:schemeClr val="accent1"/>
+          </a:fillRef>
+          <a:effectRef idx="2">
+            <a:schemeClr val="accent1"/>
+          </a:effectRef>
+          <a:fontRef idx="minor">
+            <a:schemeClr val="lt1"/>
+          </a:fontRef>
+        </p:style>
+        <p:txBody>
+          <a:bodyPr rtlCol="0" anchor="ctr" wrap="square"/>
+          <a:lstStyle/>
+          <a:p>
+            <a:pPr algn="ctr">
+              <a:defRPr sz="1400" b="1">
+                <a:solidFill>
+                  <a:srgbClr val="1B3A5C"/>
+                </a:solidFill>
+              </a:defRPr>
+            </a:pPr>
+            <a:r>
+              <a:t>Town Meeting</a:t>
+            </a:r>
+          </a:p>
+        </p:txBody>
+      </p:sp>
+      <p:cxnSp>
+        <p:nvCxnSpPr>
+          <p:cNvPr id="8" name="Connector 7"/>
+          <p:cNvCxnSpPr/>
+          <p:nvPr/>
+        </p:nvCxnSpPr>
+        <p:spPr>
+          <a:xfrm>
+            <a:off x="4366259" y="3794759"/>
+            <a:ext cx="411481" cy="0"/>
+          </a:xfrm>
+          <a:prstGeom prst="line">
+            <a:avLst/>
+          </a:prstGeom>
+          <a:ln w="25400">
+            <a:solidFill>
+              <a:srgbClr val="2E86AB"/>
+            </a:solidFill>
+            <a:tailEnd type="triangle" w="med" len="med"/>
+          </a:ln>
+        </p:spPr>
+        <p:style>
+          <a:lnRef idx="2">
+            <a:schemeClr val="accent1"/>
+          </a:lnRef>
+          <a:fillRef idx="0">
+            <a:schemeClr val="accent1"/>
+          </a:fillRef>
+          <a:effectRef idx="1">
+            <a:schemeClr val="accent1"/>
+          </a:effectRef>
+          <a:fontRef idx="minor">
+            <a:schemeClr val="tx1"/>
+          </a:fontRef>
+        </p:style>
+      </p:cxnSp>
+      <p:sp>
+        <p:nvSpPr>
+          <p:cNvPr id="9" name="Rounded Rectangle 8"/>
+          <p:cNvSpPr/>
+          <p:nvPr/>
+        </p:nvSpPr>
+        <p:spPr>
+          <a:xfrm>
+            <a:off x="4823460" y="3474720"/>
+            <a:ext cx="1463040" cy="640080"/>
+          </a:xfrm>
+          <a:prstGeom prst="roundRect">
+            <a:avLst/>
+          </a:prstGeom>
+          <a:solidFill>
+            <a:srgbClr val="FFFFFF"/>
+          </a:solidFill>
+          <a:ln w="19050">
+            <a:solidFill>
+              <a:srgbClr val="1B3A5C"/>
+            </a:solidFill>
+          </a:ln>
+        </p:spPr>
+        <p:style>
+          <a:lnRef idx="1">
+            <a:schemeClr val="accent1"/>
+          </a:lnRef>
+          <a:fillRef idx="3">
+            <a:schemeClr val="accent1"/>
+          </a:fillRef>
+          <a:effectRef idx="2">
+            <a:schemeClr val="accent1"/>
+          </a:effectRef>
+          <a:fontRef idx="minor">
+            <a:schemeClr val="lt1"/>
+          </a:fontRef>
+        </p:style>
+        <p:txBody>
+          <a:bodyPr rtlCol="0" anchor="ctr" wrap="square"/>
+          <a:lstStyle/>
+          <a:p>
+            <a:pPr algn="ctr">
+              <a:defRPr sz="1400" b="1">
+                <a:solidFill>
+                  <a:srgbClr val="1B3A5C"/>
+                </a:solidFill>
+              </a:defRPr>
+            </a:pPr>
+            <a:r>
+              <a:t>Vote</a:t>
+            </a:r>
+          </a:p>
+        </p:txBody>
+      </p:sp>
+      <p:cxnSp>
+        <p:nvCxnSpPr>
+          <p:cNvPr id="10" name="Connector 9"/>
+          <p:cNvCxnSpPr/>
+          <p:nvPr/>
+        </p:nvCxnSpPr>
+        <p:spPr>
+          <a:xfrm>
+            <a:off x="6332220" y="3794759"/>
+            <a:ext cx="411480" cy="0"/>
+          </a:xfrm>
+          <a:prstGeom prst="line">
+            <a:avLst/>
+          </a:prstGeom>
+          <a:ln w="25400">
+            <a:solidFill>
+              <a:srgbClr val="2E86AB"/>
+            </a:solidFill>
+            <a:tailEnd type="triangle" w="med" len="med"/>
+          </a:ln>
+        </p:spPr>
+        <p:style>
+          <a:lnRef idx="2">
+            <a:schemeClr val="accent1"/>
+          </a:lnRef>
+          <a:fillRef idx="0">
+            <a:schemeClr val="accent1"/>
+          </a:fillRef>
+          <a:effectRef idx="1">
+            <a:schemeClr val="accent1"/>
+          </a:effectRef>
+          <a:fontRef idx="minor">
+            <a:schemeClr val="tx1"/>
+          </a:fontRef>
+        </p:style>
+      </p:cxnSp>
+      <p:sp>
+        <p:nvSpPr>
+          <p:cNvPr id="11" name="Rounded Rectangle 10"/>
+          <p:cNvSpPr/>
+          <p:nvPr/>
+        </p:nvSpPr>
+        <p:spPr>
+          <a:xfrm>
+            <a:off x="6789420" y="3474720"/>
+            <a:ext cx="1463040" cy="640080"/>
+          </a:xfrm>
+          <a:prstGeom prst="roundRect">
+            <a:avLst/>
+          </a:prstGeom>
+          <a:solidFill>
+            <a:srgbClr val="FFFFFF"/>
+          </a:solidFill>
+          <a:ln w="19050">
+            <a:solidFill>
+              <a:srgbClr val="1B3A5C"/>
+            </a:solidFill>
+          </a:ln>
+        </p:spPr>
+        <p:style>
+          <a:lnRef idx="1">
+            <a:schemeClr val="accent1"/>
+          </a:lnRef>
+          <a:fillRef idx="3">
+            <a:schemeClr val="accent1"/>
+          </a:fillRef>
+          <a:effectRef idx="2">
+            <a:schemeClr val="accent1"/>
+          </a:effectRef>
+          <a:fontRef idx="minor">
+            <a:schemeClr val="lt1"/>
+          </a:fontRef>
+        </p:style>
+        <p:txBody>
+          <a:bodyPr rtlCol="0" anchor="ctr" wrap="square"/>
+          <a:lstStyle/>
+          <a:p>
+            <a:pPr algn="ctr">
+              <a:defRPr sz="1400" b="1">
+                <a:solidFill>
+                  <a:srgbClr val="1B3A5C"/>
+                </a:solidFill>
+              </a:defRPr>
+            </a:pPr>
+            <a:r>
+              <a:t>Decision</a:t>
             </a:r>
           </a:p>
         </p:txBody>

</xml_diff>

<commit_message>
Fix factual error: only elected Town Meeting members vote, but any resident may speak
</commit_message>
<xml_diff>
--- a/Town_Meeting_Video_Slides.pptx
+++ b/Town_Meeting_Video_Slides.pptx
@@ -3852,7 +3852,7 @@
               </a:defRPr>
             </a:pPr>
             <a:r>
-              <a:t>In Massachusetts, many towns let residents vote on big decisions.</a:t>
+              <a:t>In Massachusetts, many towns let elected Town Meeting members vote on big decisions.</a:t>
             </a:r>
           </a:p>
           <a:p>
@@ -3871,7 +3871,7 @@
               </a:defRPr>
             </a:pPr>
             <a:r>
-              <a:t>Any resident can come to Town Meeting and vote — it is like a giant classroom vote for the whole town!</a:t>
+              <a:t>Elected Town Meeting members do the voting — but any resident can come and speak their mind.</a:t>
             </a:r>
           </a:p>
           <a:p>

</xml_diff>